<commit_message>
Update CRM mock data and enhance unit tests for deal retrieval
</commit_message>
<xml_diff>
--- a/docs/deck/S4-I-24_SridharVetrivel_LiveReview_RFPCriteria_v3.pptx
+++ b/docs/deck/S4-I-24_SridharVetrivel_LiveReview_RFPCriteria_v3.pptx
@@ -5997,7 +5997,7 @@
           <a:p>
             <a:pPr algn="l"/>
             <a:r>
-              <a:rPr sz="1400" b="0" i="0">
+              <a:rPr sz="1400" b="0" i="0" dirty="0">
                 <a:solidFill>
                   <a:srgbClr val="263030"/>
                 </a:solidFill>
@@ -6164,86 +6164,6 @@
                 <a:latin typeface="Calibri"/>
               </a:rPr>
               <a:t>Budget &amp; Cost Justification</a:t>
-            </a:r>
-          </a:p>
-        </p:txBody>
-      </p:sp>
-      <p:sp>
-        <p:nvSpPr>
-          <p:cNvPr id="1043" name="Oval 1042"/>
-          <p:cNvSpPr/>
-          <p:nvPr/>
-        </p:nvSpPr>
-        <p:spPr>
-          <a:xfrm>
-            <a:off x="548640" y="4251960"/>
-            <a:ext cx="73152" cy="73152"/>
-          </a:xfrm>
-          <a:prstGeom prst="ellipse">
-            <a:avLst/>
-          </a:prstGeom>
-          <a:solidFill>
-            <a:srgbClr val="2DB6BB"/>
-          </a:solidFill>
-          <a:ln>
-            <a:noFill/>
-          </a:ln>
-          <a:effectLst/>
-        </p:spPr>
-        <p:style>
-          <a:lnRef idx="1">
-            <a:schemeClr val="accent1"/>
-          </a:lnRef>
-          <a:fillRef idx="3">
-            <a:schemeClr val="accent1"/>
-          </a:fillRef>
-          <a:effectRef idx="2">
-            <a:schemeClr val="accent1"/>
-          </a:effectRef>
-          <a:fontRef idx="minor">
-            <a:schemeClr val="lt1"/>
-          </a:fontRef>
-        </p:style>
-        <p:txBody>
-          <a:bodyPr rtlCol="0" anchor="ctr"/>
-          <a:lstStyle/>
-          <a:p>
-            <a:pPr algn="ctr"/>
-            <a:endParaRPr/>
-          </a:p>
-        </p:txBody>
-      </p:sp>
-      <p:sp>
-        <p:nvSpPr>
-          <p:cNvPr id="1044" name="TextBox 1043"/>
-          <p:cNvSpPr txBox="1"/>
-          <p:nvPr/>
-        </p:nvSpPr>
-        <p:spPr>
-          <a:xfrm>
-            <a:off x="777240" y="4123944"/>
-            <a:ext cx="5212080" cy="365760"/>
-          </a:xfrm>
-          <a:prstGeom prst="rect">
-            <a:avLst/>
-          </a:prstGeom>
-          <a:noFill/>
-        </p:spPr>
-        <p:txBody>
-          <a:bodyPr wrap="square" lIns="0" tIns="0" rIns="0" bIns="0" anchor="t">
-            <a:spAutoFit/>
-          </a:bodyPr>
-          <a:lstStyle/>
-          <a:p>
-            <a:pPr algn="l"/>
-            <a:r>
-              <a:rPr sz="1400" b="0" i="0">
-                <a:solidFill>
-                  <a:srgbClr val="263030"/>
-                </a:solidFill>
-                <a:latin typeface="Calibri"/>
-              </a:rPr>
-              <a:t>Timeline Feasibility</a:t>
             </a:r>
           </a:p>
         </p:txBody>
@@ -8882,7 +8802,7 @@
           <a:p>
             <a:pPr algn="ctr"/>
             <a:r>
-              <a:rPr sz="1050" b="1" i="0">
+              <a:rPr sz="1050" b="1" i="0" dirty="0">
                 <a:solidFill>
                   <a:srgbClr val="1971C2"/>
                 </a:solidFill>
@@ -8952,9 +8872,9 @@
           <a:p>
             <a:pPr algn="ctr"/>
             <a:r>
-              <a:rPr sz="1050" b="1" i="0">
-                <a:solidFill>
-                  <a:srgbClr val="C92A2A"/>
+              <a:rPr sz="1050" b="1" i="0" strike="sngStrike">
+                <a:solidFill>
+                  <a:srgbClr val="FF0000"/>
                 </a:solidFill>
                 <a:latin typeface="Calibri"/>
               </a:rPr>
@@ -9092,7 +9012,7 @@
           <a:p>
             <a:pPr algn="ctr"/>
             <a:r>
-              <a:rPr sz="1050" b="1" i="0">
+              <a:rPr sz="1050" b="1" i="0" dirty="0">
                 <a:solidFill>
                   <a:srgbClr val="E67700"/>
                 </a:solidFill>
@@ -9145,6 +9065,41 @@
           </a:fontRef>
         </p:style>
       </p:cxnSp>
+      <p:sp>
+        <p:nvSpPr>
+          <p:cNvPr id="2" name="TextBox 1">
+            <a:extLst>
+              <a:ext uri="{FF2B5EF4-FFF2-40B4-BE49-F238E27FC236}">
+                <a16:creationId xmlns:a16="http://schemas.microsoft.com/office/drawing/2014/main" id="{0253BB2E-C1D5-C7DE-8415-78EEE9DE920F}"/>
+              </a:ext>
+            </a:extLst>
+          </p:cNvPr>
+          <p:cNvSpPr txBox="1"/>
+          <p:nvPr/>
+        </p:nvSpPr>
+        <p:spPr>
+          <a:xfrm>
+            <a:off x="402748" y="5353150"/>
+            <a:ext cx="4603592" cy="253916"/>
+          </a:xfrm>
+          <a:prstGeom prst="rect">
+            <a:avLst/>
+          </a:prstGeom>
+          <a:noFill/>
+        </p:spPr>
+        <p:txBody>
+          <a:bodyPr wrap="square" rtlCol="0">
+            <a:spAutoFit/>
+          </a:bodyPr>
+          <a:lstStyle/>
+          <a:p>
+            <a:r>
+              <a:rPr lang="en-IN" sz="1050" dirty="0"/>
+              <a:t>NOTE: All the data are synthetic*</a:t>
+            </a:r>
+          </a:p>
+        </p:txBody>
+      </p:sp>
     </p:spTree>
     <p:extLst>
       <p:ext uri="{BB962C8B-B14F-4D97-AF65-F5344CB8AC3E}">
@@ -15479,20 +15434,20 @@
 </file>
 
 <file path=customXml/item1.xml><?xml version="1.0" encoding="utf-8"?>
+<p:properties xmlns:p="http://schemas.microsoft.com/office/2006/metadata/properties" xmlns:xsi="http://www.w3.org/2001/XMLSchema-instance" xmlns:pc="http://schemas.microsoft.com/office/infopath/2007/PartnerControls">
+  <documentManagement>
+    <_activity xmlns="85917f08-b411-4c8c-b73b-478edaa64b5d" xsi:nil="true"/>
+  </documentManagement>
+</p:properties>
+</file>
+
+<file path=customXml/item2.xml><?xml version="1.0" encoding="utf-8"?>
 <?mso-contentType ?>
 <FormTemplates xmlns="http://schemas.microsoft.com/sharepoint/v3/contenttype/forms">
   <Display>DocumentLibraryForm</Display>
   <Edit>DocumentLibraryForm</Edit>
   <New>DocumentLibraryForm</New>
 </FormTemplates>
-</file>
-
-<file path=customXml/item2.xml><?xml version="1.0" encoding="utf-8"?>
-<p:properties xmlns:p="http://schemas.microsoft.com/office/2006/metadata/properties" xmlns:xsi="http://www.w3.org/2001/XMLSchema-instance" xmlns:pc="http://schemas.microsoft.com/office/infopath/2007/PartnerControls">
-  <documentManagement>
-    <_activity xmlns="85917f08-b411-4c8c-b73b-478edaa64b5d" xsi:nil="true"/>
-  </documentManagement>
-</p:properties>
 </file>
 
 <file path=customXml/item3.xml><?xml version="1.0" encoding="utf-8"?>
@@ -15729,12 +15684,6 @@
 </file>
 
 <file path=customXml/itemProps1.xml><?xml version="1.0" encoding="utf-8"?>
-<ds:datastoreItem xmlns:ds="http://schemas.openxmlformats.org/officeDocument/2006/customXml" ds:itemID="{BDF03512-25DF-493B-9B53-51BE253359EC}">
-  <ds:schemaRefs/>
-</ds:datastoreItem>
-</file>
-
-<file path=customXml/itemProps2.xml><?xml version="1.0" encoding="utf-8"?>
 <ds:datastoreItem xmlns:ds="http://schemas.openxmlformats.org/officeDocument/2006/customXml" ds:itemID="{66373FA7-71C7-4D16-9EDE-82A2EECC32F9}">
   <ds:schemaRefs>
     <ds:schemaRef ds:uri="http://schemas.microsoft.com/office/2006/documentManagement/types"/>
@@ -15748,6 +15697,12 @@
     <ds:schemaRef ds:uri="http://schemas.microsoft.com/office/infopath/2007/PartnerControls"/>
     <ds:schemaRef ds:uri="http://www.w3.org/XML/1998/namespace"/>
   </ds:schemaRefs>
+</ds:datastoreItem>
+</file>
+
+<file path=customXml/itemProps2.xml><?xml version="1.0" encoding="utf-8"?>
+<ds:datastoreItem xmlns:ds="http://schemas.openxmlformats.org/officeDocument/2006/customXml" ds:itemID="{BDF03512-25DF-493B-9B53-51BE253359EC}">
+  <ds:schemaRefs/>
 </ds:datastoreItem>
 </file>
 

</xml_diff>